<commit_message>
Made cpp and python deepstream independent to each other and modified the whole codebase
</commit_message>
<xml_diff>
--- a/DeepStream_Surveillance_Presentation.pptx
+++ b/DeepStream_Surveillance_Presentation.pptx
@@ -12,6 +12,8 @@
     <p:sldId id="260" r:id="rId12"/>
     <p:sldId id="261" r:id="rId13"/>
     <p:sldId id="262" r:id="rId14"/>
+    <p:sldId id="263" r:id="rId15"/>
+    <p:sldId id="264" r:id="rId16"/>
   </p:sldIdLst>
   <p:sldSz cx="12191695" cy="6858000" type="screen4x3"/>
   <p:notesSz cx="6858000" cy="9144000"/>
@@ -513,13 +515,13 @@
           </a:p>
           <a:p>
             <a:r>
-              <a:t>Good morning/afternoon everyone. Today, I am presenting the transition of our industrial surveillance system to NVIDIA DeepStream hardware acceleration.</a:t>
+              <a:t>Good morning/afternoon. Today I am going to walk you through our NVIDIA DeepStream hardware-accelerated surveillance pipeline. We have recently completed a total cleanup of our workspace, completely separating our Python GStreamer-bound pipeline and our C++ Native pipeline into 100% independent directories.</a:t>
             </a:r>
           </a:p>
           <a:p/>
           <a:p>
             <a:r>
-              <a:t>We have recently completed a major restructuring of our codebase to clean up legacy CPU pipelines and establish two distinct ways of executing DeepStream: a C++ native application and a custom Python GStreamer pipeline. I will explain how they differ, which one is best for our use case, and walk you through the restructured architecture.</a:t>
+              <a:t>This presentation will focus exclusively on how the frame data travels from the RTSP camera streams, through our neural network engines, matches identities against our database, and draws overlays using On-Screen Display (OSD).</a:t>
             </a:r>
           </a:p>
         </p:txBody>
@@ -594,13 +596,13 @@
           </a:p>
           <a:p>
             <a:r>
-              <a:t>To understand why we moved to DeepStream, let's look at the bottleneck we had before. Our legacy pipeline used OpenCV, which required decoding videos on the CPU, copying those frames into CPU RAM, and sending them back and forth to the GPU for inference. This limited our capability to scale to multiple high-res feeds.</a:t>
+              <a:t>Let's trace the journey of a single frame. The camera streams are ingested via RTSP. The GStreamer RTSP source elements route the frames to 'nvv4l2decoder', which handles the video decoding directly on the GPU hardware. The stream multiplexer then bundles the decoded frames from all active camera sources into a single memory batch.</a:t>
             </a:r>
           </a:p>
           <a:p/>
           <a:p>
             <a:r>
-              <a:t>NVIDIA DeepStream completely eliminates this. It uses specialized hardware decoders to pull H.264 video streams directly into GPU memory. From decoding to scaling, object detection, tracking, and OSD drawing, the frames never leave the GPU. This is known as Zero-Copy memory flow, which dramatically reduces CPU utilization.</a:t>
+              <a:t>Next, our Primary Inference element runs the SCRFD face detector. Because GStreamer needs to convert model tensors into bounding box coordinates, we compile a custom C++ shared library parser. Once the face boxes are decoded, the NvDCF Tracker assigns tracking IDs. These tracked face crops are passed through the secondary engine, AdaFace, which outputs 512-dimensional vectors. Finally, the On-Screen Display (OSD) overlay element renders these labels onto the display window.</a:t>
             </a:r>
           </a:p>
         </p:txBody>
@@ -675,19 +677,13 @@
           </a:p>
           <a:p>
             <a:r>
-              <a:t>We have restructured our workspace to separate the two different ways of running DeepStream:</a:t>
+              <a:t>To prevent any code overlap or dependency issues, we have split the DeepStream implementation into two separate independent folders at the root level of our workspace.</a:t>
             </a:r>
           </a:p>
           <a:p/>
           <a:p>
             <a:r>
-              <a:t>First, we have the C++ Native pipeline in 'cpp_deepstream_pipeline/'. It is run by executing NVIDIA's pre-compiled deepstream-app utility against config files. It compiles TensorRT engines and draws bounding boxes very quickly, but it is a generic tool. It cannot read our Python database or run our alerts logic.</a:t>
-            </a:r>
-          </a:p>
-          <a:p/>
-          <a:p>
-            <a:r>
-              <a:t>Second, we have the Python Custom pipeline in 'python_deepstream_pipeline/'. It creates the same GStreamer elements but wraps them in a Python process. This allows us to intercept the output tensors, match them against our FAISS face database, and trigger our custom logging and WhatsApp alerting systems.</a:t>
+              <a:t>In 'python_deepstream_pipeline/', we have all the scripts, properties, GStreamer configs, and custom parser source files required to run the Python bindings. In 'cpp_deepstream_pipeline/', we have the duplicate configs and parser sources required to run the native C++ 'deepstream-app'. If we delete one folder, the other remains fully functional. There is zero directory coupling.</a:t>
             </a:r>
           </a:p>
         </p:txBody>
@@ -762,13 +758,13 @@
           </a:p>
           <a:p>
             <a:r>
-              <a:t>If you are wondering which option we will actually deploy, the answer is Option B (the Python pipeline).</a:t>
+              <a:t>The C++ native pipeline (Option A) is driven entirely by configuration files. We execute it using the pre-compiled 'deepstream-app' binary. The master configuration maps all our inputs and references sub-configuration files for inference.</a:t>
             </a:r>
           </a:p>
           <a:p/>
           <a:p>
             <a:r>
-              <a:t>The reason is that Option B integrates all our business logic. While the video decoding, face detection, and embedding generation run entirely on the GPU, the Python pad probe acts as the coordinator. It queries the FAISS database, aggregates embeddings over multiple frames (so one blurry face doesn't ruin the accuracy), and submits snapshots and log events asynchronously to prevent blocking the GPU. It gives us all the hardware acceleration of C++ but with the full intelligence of our custom Python codebase.</a:t>
+              <a:t>To handle our face models, the GStreamer elements load our custom-built libraries. The SCRFD bounding box parser is compiled into a shared object. The AdaFace recognizer custom parser loads the gallery database from a flat text file 'gallery_embeddings.txt' and handles matching calculations inside C++ natively.</a:t>
             </a:r>
           </a:p>
         </p:txBody>
@@ -843,13 +839,13 @@
           </a:p>
           <a:p>
             <a:r>
-              <a:t>To make the project folder easy to maintain, we removed all unused files. Previously, the repository was cluttered with a parallel OpenCV pipeline (entry_pipeline) and files for CPU-based tracking and blur checks.</a:t>
+              <a:t>The Python pipeline (Option B) constructs the same GStreamer pipeline but wraps it inside a Python process. This allows us to leverage python-level libraries like NumPy and FAISS.</a:t>
             </a:r>
           </a:p>
           <a:p/>
           <a:p>
             <a:r>
-              <a:t>Now, all legacy folders are gone, and we have cleanly separated the Python and C++ DeepStream workflows at the root level in 'python_deepstream_pipeline/' and 'cpp_deepstream_pipeline/'. The shared backend functions (like FAISS matching, database management, and asynchronous I/O saving) remain organized in the central 'core/' directory, keeping the codebase dry and modular.</a:t>
+              <a:t>We attach a 'pad probe' callback on the secondary inference Gst.Pad. Every time a batch is processed, GStreamer invokes our Python function. This function extracts the generated face embeddings and matches them against our binary FAISS file. We also apply our temporal consensus aggregator, meaning we collect face signatures across multiple frames before making a final decision, drastically improving matching accuracy.</a:t>
             </a:r>
           </a:p>
         </p:txBody>
@@ -924,13 +920,13 @@
           </a:p>
           <a:p>
             <a:r>
-              <a:t>Let's walk through the data flow. A critical design goal was to keep the AI pipeline fast. Writing to files, serving APIs, or sending WhatsApp messages are slow tasks that would block real-time GPU processing.</a:t>
+              <a:t>A key detail of both pipelines is their performance optimization. By setting 'nvbuf-memory-type=0', we tell GStreamer to use NVIDIA Video Memory (NVMM).</a:t>
             </a:r>
           </a:p>
           <a:p/>
           <a:p>
             <a:r>
-              <a:t>Our architecture decouples these. DeepStream writes event data locally and asynchronously to 'logs/events.jsonl'. FastAPI tails this file and serves it over a lightweight network endpoint. The WhatsApp bot is completely independent—it queries the FastAPI server and handles Selenium automation in its own separate process. If WhatsApp lags, the surveillance system continues running at full speed without interruptions.</a:t>
+              <a:t>Because of this, the video frames stay entirely inside the GPU VRAM as they are decoded, scaled, and analyzed. The only things passed to the CPU are lightweight metadata—such as bounding box coordinates and the 512-dimension embedding vectors. The heavy video frame matrix is never copied to the CPU RAM, except when we lazily copy a single snapshot frame during an alert trigger. This ensures maximum throughput.</a:t>
             </a:r>
           </a:p>
         </p:txBody>
@@ -1005,13 +1001,157 @@
           </a:p>
           <a:p>
             <a:r>
-              <a:t>In summary, we have transitioned from a slow, CPU-bottlenecked OpenCV model to a fully GPU-accelerated NVIDIA DeepStream framework. We have segregated our pipelines so that the C++ configurations and custom C++ parsers live in 'cpp_deepstream_pipeline/', and our production-ready Python coordination script lives in 'python_deepstream_pipeline/'.</a:t>
-            </a:r>
-          </a:p>
-          <a:p/>
-          <a:p>
-            <a:r>
-              <a:t>The system is now fully structured, cleaned, and optimized. Our next step is to run it on our CUDA-compatible target GPU server to measure the frame rate improvements across our multiple industrial cameras. Thank you, and I am happy to take any questions.</a:t>
+              <a:t>To summarize our engine configurations, the multiplexer is tuned to receive three active camera streams. For efficiency, the primary detector (SCRFD) is batch-configured to process exactly 3 frames in a single pass. The secondary classifier (AdaFace) operates on a batch size of 16, allowing it to handle situations where multiple faces are detected across the streams simultaneously without bottlenecking the pipeline.</a:t>
+            </a:r>
+          </a:p>
+        </p:txBody>
+      </p:sp>
+      <p:sp>
+        <p:nvSpPr>
+          <p:cNvPr id="4" name="Slide Number Placeholder 3"/>
+          <p:cNvSpPr>
+            <a:spLocks noGrp="1"/>
+          </p:cNvSpPr>
+          <p:nvPr>
+            <p:ph type="sldNum" idx="5" sz="quarter"/>
+          </p:nvPr>
+        </p:nvSpPr>
+        <p:spPr/>
+      </p:sp>
+    </p:spTree>
+  </p:cSld>
+  <p:clrMapOvr>
+    <a:masterClrMapping/>
+  </p:clrMapOvr>
+</p:notes>
+</file>
+
+<file path=ppt/notesSlides/notesSlide8.xml><?xml version="1.0" encoding="utf-8"?>
+<p:notes xmlns:a="http://schemas.openxmlformats.org/drawingml/2006/main" xmlns:p="http://schemas.openxmlformats.org/presentationml/2006/main" xmlns:r="http://schemas.openxmlformats.org/officeDocument/2006/relationships">
+  <p:cSld>
+    <p:spTree>
+      <p:nvGrpSpPr>
+        <p:cNvPr id="1" name=""/>
+        <p:cNvGrpSpPr/>
+        <p:nvPr/>
+      </p:nvGrpSpPr>
+      <p:grpSpPr>
+        <a:xfrm>
+          <a:off x="0" y="0"/>
+          <a:ext cx="0" cy="0"/>
+          <a:chOff x="0" y="0"/>
+          <a:chExt cx="0" cy="0"/>
+        </a:xfrm>
+      </p:grpSpPr>
+      <p:sp>
+        <p:nvSpPr>
+          <p:cNvPr id="2" name="Slide Image Placeholder 1"/>
+          <p:cNvSpPr>
+            <a:spLocks noGrp="1"/>
+          </p:cNvSpPr>
+          <p:nvPr>
+            <p:ph type="sldImg" idx="2"/>
+          </p:nvPr>
+        </p:nvSpPr>
+        <p:spPr/>
+      </p:sp>
+      <p:sp>
+        <p:nvSpPr>
+          <p:cNvPr id="3" name="Notes Placeholder 2"/>
+          <p:cNvSpPr>
+            <a:spLocks noGrp="1"/>
+          </p:cNvSpPr>
+          <p:nvPr>
+            <p:ph type="body" idx="3" sz="quarter"/>
+          </p:nvPr>
+        </p:nvSpPr>
+        <p:spPr/>
+        <p:txBody>
+          <a:bodyPr/>
+          <a:lstStyle/>
+          <a:p>
+            <a:r>
+              <a:t>SPEAKER NOTES:</a:t>
+            </a:r>
+          </a:p>
+          <a:p>
+            <a:r>
+              <a:t>Finally, here are the step-by-step commands to run the pipelines inside our DeepStream Docker container. Since the directories are completely separated, you compile the C++ parsers within their respective directories. For Python, you compile the custom parsers in '/app/python_deepstream_pipeline/custom_parser/' and launch using 'python3'. For C++, you compile the custom parsers in '/app/cpp_deepstream_pipeline/custom_parser/' and launch the compiled binary using 'deepstream-app'. Both are fully independent and operational.</a:t>
+            </a:r>
+          </a:p>
+        </p:txBody>
+      </p:sp>
+      <p:sp>
+        <p:nvSpPr>
+          <p:cNvPr id="4" name="Slide Number Placeholder 3"/>
+          <p:cNvSpPr>
+            <a:spLocks noGrp="1"/>
+          </p:cNvSpPr>
+          <p:nvPr>
+            <p:ph type="sldNum" idx="5" sz="quarter"/>
+          </p:nvPr>
+        </p:nvSpPr>
+        <p:spPr/>
+      </p:sp>
+    </p:spTree>
+  </p:cSld>
+  <p:clrMapOvr>
+    <a:masterClrMapping/>
+  </p:clrMapOvr>
+</p:notes>
+</file>
+
+<file path=ppt/notesSlides/notesSlide9.xml><?xml version="1.0" encoding="utf-8"?>
+<p:notes xmlns:a="http://schemas.openxmlformats.org/drawingml/2006/main" xmlns:p="http://schemas.openxmlformats.org/presentationml/2006/main" xmlns:r="http://schemas.openxmlformats.org/officeDocument/2006/relationships">
+  <p:cSld>
+    <p:spTree>
+      <p:nvGrpSpPr>
+        <p:cNvPr id="1" name=""/>
+        <p:cNvGrpSpPr/>
+        <p:nvPr/>
+      </p:nvGrpSpPr>
+      <p:grpSpPr>
+        <a:xfrm>
+          <a:off x="0" y="0"/>
+          <a:ext cx="0" cy="0"/>
+          <a:chOff x="0" y="0"/>
+          <a:chExt cx="0" cy="0"/>
+        </a:xfrm>
+      </p:grpSpPr>
+      <p:sp>
+        <p:nvSpPr>
+          <p:cNvPr id="2" name="Slide Image Placeholder 1"/>
+          <p:cNvSpPr>
+            <a:spLocks noGrp="1"/>
+          </p:cNvSpPr>
+          <p:nvPr>
+            <p:ph type="sldImg" idx="2"/>
+          </p:nvPr>
+        </p:nvSpPr>
+        <p:spPr/>
+      </p:sp>
+      <p:sp>
+        <p:nvSpPr>
+          <p:cNvPr id="3" name="Notes Placeholder 2"/>
+          <p:cNvSpPr>
+            <a:spLocks noGrp="1"/>
+          </p:cNvSpPr>
+          <p:nvPr>
+            <p:ph type="body" idx="3" sz="quarter"/>
+          </p:nvPr>
+        </p:nvSpPr>
+        <p:spPr/>
+        <p:txBody>
+          <a:bodyPr/>
+          <a:lstStyle/>
+          <a:p>
+            <a:r>
+              <a:t>SPEAKER NOTES:</a:t>
+            </a:r>
+          </a:p>
+          <a:p>
+            <a:r>
+              <a:t>After the DeepStream pipeline finishes running, the downstream flow begins. The pipeline saves face snapshot files and logs events locally. Our FastAPI server acts as the central data hub, tailing the log file and exposing event history via API. Finally, the Selenium-based WhatsApp Bot polls this API and automates WhatsApp Web to send immediate notifications. Because these services run asynchronously, they do not impact the high-performance video processing pipeline.</a:t>
             </a:r>
           </a:p>
         </p:txBody>
@@ -4048,7 +4188,7 @@
           <a:lstStyle/>
           <a:p>
             <a:pPr>
-              <a:defRPr sz="4400" b="1">
+              <a:defRPr sz="4000" b="1">
                 <a:solidFill>
                   <a:srgbClr val="10B981"/>
                 </a:solidFill>
@@ -4056,12 +4196,12 @@
               </a:defRPr>
             </a:pPr>
             <a:r>
-              <a:t>NVIDIA DEEPSTREAM TRANSITION</a:t>
+              <a:t>NVIDIA DEEPSTREAM SURVEILLANCE PIPELINE</a:t>
             </a:r>
           </a:p>
           <a:p>
             <a:pPr>
-              <a:defRPr sz="2800">
+              <a:defRPr sz="2600">
                 <a:solidFill>
                   <a:srgbClr val="F1F5F9"/>
                 </a:solidFill>
@@ -4069,7 +4209,7 @@
               </a:defRPr>
             </a:pPr>
             <a:r>
-              <a:t>High-Performance Multi-Camera AI Surveillance &amp; Recognition</a:t>
+              <a:t>Restructured Isolated Python &amp; C++ Architectures</a:t>
             </a:r>
           </a:p>
         </p:txBody>
@@ -4105,7 +4245,7 @@
               </a:defRPr>
             </a:pPr>
             <a:r>
-              <a:t>Ha-Meem Group Industrial Surveillance Architecture</a:t>
+              <a:t>Ha-Meem Group AI Surveillance Engineering</a:t>
             </a:r>
           </a:p>
           <a:p>
@@ -4118,7 +4258,7 @@
               </a:defRPr>
             </a:pPr>
             <a:r>
-              <a:t>Presenting: Reorganized Pipeline Structure &amp; Hardware Acceleration Strategy</a:t>
+              <a:t>Technical Walkthrough: RTSP Ingestion ➔ Detection ➔ Tracking ➔ Recognition ➔ OSD Overlay</a:t>
             </a:r>
           </a:p>
         </p:txBody>
@@ -4172,7 +4312,7 @@
           <a:lstStyle/>
           <a:p>
             <a:pPr>
-              <a:defRPr sz="3800" b="1">
+              <a:defRPr sz="3600" b="1">
                 <a:solidFill>
                   <a:srgbClr val="F1F5F9"/>
                 </a:solidFill>
@@ -4180,7 +4320,7 @@
               </a:defRPr>
             </a:pPr>
             <a:r>
-              <a:t>The Challenge: CPU Bottlenecks vs. GPU Acceleration</a:t>
+              <a:t>DeepStream Pipeline: RTSP Ingestion to OSD Rendering</a:t>
             </a:r>
           </a:p>
         </p:txBody>
@@ -4193,8 +4333,8 @@
         </p:nvSpPr>
         <p:spPr>
           <a:xfrm>
-            <a:off x="685800" y="1645920"/>
-            <a:ext cx="5120640" cy="4114800"/>
+            <a:off x="685800" y="1463040"/>
+            <a:ext cx="10817352" cy="4572000"/>
           </a:xfrm>
           <a:prstGeom prst="rect">
             <a:avLst/>
@@ -4206,173 +4346,166 @@
             <a:spAutoFit/>
           </a:bodyPr>
           <a:lstStyle/>
-          <a:p>
-            <a:pPr>
-              <a:defRPr sz="2200" b="1">
-                <a:solidFill>
-                  <a:srgbClr val="EF4444"/>
-                </a:solidFill>
-                <a:latin typeface="Calibri"/>
-              </a:defRPr>
-            </a:pPr>
-            <a:r>
-              <a:t>Traditional OpenCV Pipeline (Legacy)</a:t>
-            </a:r>
-          </a:p>
+          <a:p/>
           <a:p>
             <a:pPr>
               <a:spcAft>
-                <a:spcPts val="800"/>
+                <a:spcPts val="600"/>
               </a:spcAft>
-              <a:defRPr sz="1600">
+              <a:defRPr sz="1500" b="1">
+                <a:solidFill>
+                  <a:srgbClr val="3B82F6"/>
+                </a:solidFill>
+              </a:defRPr>
+            </a:pPr>
+            <a:r>
+              <a:t>➔ 1. Stream Ingestion (rtspsrc ➔ nvv4l2decoder): </a:t>
+            </a:r>
+            <a:r>
+              <a:rPr sz="1300">
                 <a:solidFill>
                   <a:srgbClr val="F1F5F9"/>
                 </a:solidFill>
-              </a:defRPr>
-            </a:pPr>
-            <a:r>
-              <a:t>• Relies heavily on Python threads and CPU decoding</a:t>
+              </a:rPr>
+              <a:t>H.264 camera feeds are captured and decoded natively on the GPU's hardware decoder.</a:t>
             </a:r>
           </a:p>
           <a:p>
             <a:pPr>
               <a:spcAft>
-                <a:spcPts val="800"/>
+                <a:spcPts val="600"/>
               </a:spcAft>
-              <a:defRPr sz="1600">
+              <a:defRPr sz="1500" b="1">
+                <a:solidFill>
+                  <a:srgbClr val="3B82F6"/>
+                </a:solidFill>
+              </a:defRPr>
+            </a:pPr>
+            <a:r>
+              <a:t>➔ 2. Stream Multiplexing (nvstreammux): </a:t>
+            </a:r>
+            <a:r>
+              <a:rPr sz="1300">
                 <a:solidFill>
                   <a:srgbClr val="F1F5F9"/>
                 </a:solidFill>
-              </a:defRPr>
-            </a:pPr>
-            <a:r>
-              <a:t>• Frames must be copied repeatedly between GPU and CPU RAM</a:t>
+              </a:rPr>
+              <a:t>Frames from multiple RTSP streams are batch-assembled into a single composite memory buffer.</a:t>
             </a:r>
           </a:p>
           <a:p>
             <a:pPr>
               <a:spcAft>
-                <a:spcPts val="800"/>
+                <a:spcPts val="600"/>
               </a:spcAft>
-              <a:defRPr sz="1600">
+              <a:defRPr sz="1500" b="1">
+                <a:solidFill>
+                  <a:srgbClr val="3B82F6"/>
+                </a:solidFill>
+              </a:defRPr>
+            </a:pPr>
+            <a:r>
+              <a:t>➔ 3. Primary Inference: Face Detection (nvinfer - SCRFD): </a:t>
+            </a:r>
+            <a:r>
+              <a:rPr sz="1300">
                 <a:solidFill>
                   <a:srgbClr val="F1F5F9"/>
                 </a:solidFill>
-              </a:defRPr>
-            </a:pPr>
-            <a:r>
-              <a:t>• Inference is serialized or split across subprocesses</a:t>
+              </a:rPr>
+              <a:t>Hardware-accelerated face detection scans the batch and extracts raw coordinates and landmarks.</a:t>
             </a:r>
           </a:p>
           <a:p>
             <a:pPr>
               <a:spcAft>
-                <a:spcPts val="800"/>
+                <a:spcPts val="600"/>
               </a:spcAft>
-              <a:defRPr sz="1600">
+              <a:defRPr sz="1500" b="1">
+                <a:solidFill>
+                  <a:srgbClr val="3B82F6"/>
+                </a:solidFill>
+              </a:defRPr>
+            </a:pPr>
+            <a:r>
+              <a:t>➔ 4. Bounding Box Decoding (libnvdsinfer_custom_impl_scrfd.so): </a:t>
+            </a:r>
+            <a:r>
+              <a:rPr sz="1300">
                 <a:solidFill>
                   <a:srgbClr val="F1F5F9"/>
                 </a:solidFill>
-              </a:defRPr>
-            </a:pPr>
-            <a:r>
-              <a:t>• Result: Scalability is bottlenecked, causing frame drop and high CPU usage</a:t>
-            </a:r>
-          </a:p>
-        </p:txBody>
-      </p:sp>
-      <p:sp>
-        <p:nvSpPr>
-          <p:cNvPr id="4" name="TextBox 3"/>
-          <p:cNvSpPr txBox="1"/>
-          <p:nvPr/>
-        </p:nvSpPr>
-        <p:spPr>
-          <a:xfrm>
-            <a:off x="6217920" y="1645920"/>
-            <a:ext cx="5120640" cy="4114800"/>
-          </a:xfrm>
-          <a:prstGeom prst="rect">
-            <a:avLst/>
-          </a:prstGeom>
-          <a:noFill/>
-        </p:spPr>
-        <p:txBody>
-          <a:bodyPr wrap="square">
-            <a:spAutoFit/>
-          </a:bodyPr>
-          <a:lstStyle/>
-          <a:p>
-            <a:pPr>
-              <a:defRPr sz="2200" b="1">
-                <a:solidFill>
-                  <a:srgbClr val="10B981"/>
-                </a:solidFill>
-                <a:latin typeface="Calibri"/>
-              </a:defRPr>
-            </a:pPr>
-            <a:r>
-              <a:t>NVIDIA DeepStream Pipeline</a:t>
+              </a:rPr>
+              <a:t>A custom compiled C++ parser decodes the SCRFD output tensors into bounding box coordinates.</a:t>
             </a:r>
           </a:p>
           <a:p>
             <a:pPr>
               <a:spcAft>
-                <a:spcPts val="800"/>
+                <a:spcPts val="600"/>
               </a:spcAft>
-              <a:defRPr sz="1600">
+              <a:defRPr sz="1500" b="1">
+                <a:solidFill>
+                  <a:srgbClr val="3B82F6"/>
+                </a:solidFill>
+              </a:defRPr>
+            </a:pPr>
+            <a:r>
+              <a:t>➔ 5. Object Tracking (nvtracker - NvDCF): </a:t>
+            </a:r>
+            <a:r>
+              <a:rPr sz="1300">
                 <a:solidFill>
                   <a:srgbClr val="F1F5F9"/>
                 </a:solidFill>
-              </a:defRPr>
-            </a:pPr>
-            <a:r>
-              <a:t>• Video decoding is hardware-accelerated directly on the GPU (NVDEC)</a:t>
+              </a:rPr>
+              <a:t>NVIDIA's DCF tracker links face boxes across frames, assigning persistent 'Track IDs' to each person.</a:t>
             </a:r>
           </a:p>
           <a:p>
             <a:pPr>
               <a:spcAft>
-                <a:spcPts val="800"/>
+                <a:spcPts val="600"/>
               </a:spcAft>
-              <a:defRPr sz="1600">
+              <a:defRPr sz="1500" b="1">
+                <a:solidFill>
+                  <a:srgbClr val="3B82F6"/>
+                </a:solidFill>
+              </a:defRPr>
+            </a:pPr>
+            <a:r>
+              <a:t>➔ 6. Secondary Inference: Embedding (nvinfer - AdaFace): </a:t>
+            </a:r>
+            <a:r>
+              <a:rPr sz="1300">
                 <a:solidFill>
                   <a:srgbClr val="F1F5F9"/>
                 </a:solidFill>
-              </a:defRPr>
-            </a:pPr>
-            <a:r>
-              <a:t>• Zero-Copy memory flow (frames stay in GPU memory (NVMM) during processing)</a:t>
+              </a:rPr>
+              <a:t>Passes tracked face crops through AdaFace to extract 512-dimension vector representations.</a:t>
             </a:r>
           </a:p>
           <a:p>
             <a:pPr>
               <a:spcAft>
-                <a:spcPts val="800"/>
+                <a:spcPts val="600"/>
               </a:spcAft>
-              <a:defRPr sz="1600">
+              <a:defRPr sz="1500" b="1">
+                <a:solidFill>
+                  <a:srgbClr val="3B82F6"/>
+                </a:solidFill>
+              </a:defRPr>
+            </a:pPr>
+            <a:r>
+              <a:t>➔ 7. Overlays &amp; Rendering (nvdsosd): </a:t>
+            </a:r>
+            <a:r>
+              <a:rPr sz="1300">
                 <a:solidFill>
                   <a:srgbClr val="F1F5F9"/>
                 </a:solidFill>
-              </a:defRPr>
-            </a:pPr>
-            <a:r>
-              <a:t>• TensorRT handles execution of SCRFD &amp; AdaFace at sub-millisecond speeds</a:t>
-            </a:r>
-          </a:p>
-          <a:p>
-            <a:pPr>
-              <a:spcAft>
-                <a:spcPts val="800"/>
-              </a:spcAft>
-              <a:defRPr sz="1600">
-                <a:solidFill>
-                  <a:srgbClr val="F1F5F9"/>
-                </a:solidFill>
-              </a:defRPr>
-            </a:pPr>
-            <a:r>
-              <a:t>• Capable of streaming multiple camera feeds concurrently at full FPS</a:t>
+              </a:rPr>
+              <a:t>Labels recognized names/known statuses (with green boxes) or UNKNOWN tags (with red boxes) onto the video frame.</a:t>
             </a:r>
           </a:p>
         </p:txBody>
@@ -4426,7 +4559,7 @@
           <a:lstStyle/>
           <a:p>
             <a:pPr>
-              <a:defRPr sz="3800" b="1">
+              <a:defRPr sz="3600" b="1">
                 <a:solidFill>
                   <a:srgbClr val="F1F5F9"/>
                 </a:solidFill>
@@ -4434,7 +4567,7 @@
               </a:defRPr>
             </a:pPr>
             <a:r>
-              <a:t>The Restructured Repository: Two Execution Options</a:t>
+              <a:t>Isolated Folders: Complete Segregation of Structures</a:t>
             </a:r>
           </a:p>
         </p:txBody>
@@ -4462,90 +4595,63 @@
           <a:lstStyle/>
           <a:p>
             <a:pPr>
+              <a:spcAft>
+                <a:spcPts val="1000"/>
+              </a:spcAft>
               <a:defRPr sz="2200" b="1">
                 <a:solidFill>
-                  <a:srgbClr val="3B82F6"/>
+                  <a:srgbClr val="10B981"/>
                 </a:solidFill>
                 <a:latin typeface="Calibri"/>
               </a:defRPr>
             </a:pPr>
             <a:r>
-              <a:t>1. C++ Native Application (Option A)</a:t>
+              <a:t>python_deepstream_pipeline/</a:t>
             </a:r>
           </a:p>
           <a:p>
             <a:pPr>
-              <a:spcAft>
-                <a:spcPts val="800"/>
-              </a:spcAft>
-              <a:defRPr sz="1600">
+              <a:defRPr sz="1300">
                 <a:solidFill>
                   <a:srgbClr val="F1F5F9"/>
                 </a:solidFill>
+                <a:latin typeface="Courier New"/>
               </a:defRPr>
             </a:pPr>
             <a:r>
-              <a:t>• Orchestrated natively in compiled C/C++</a:t>
-            </a:r>
-          </a:p>
-          <a:p>
-            <a:pPr>
-              <a:spcAft>
-                <a:spcPts val="800"/>
-              </a:spcAft>
-              <a:defRPr sz="1600">
-                <a:solidFill>
-                  <a:srgbClr val="F1F5F9"/>
-                </a:solidFill>
-              </a:defRPr>
-            </a:pPr>
-            <a:r>
-              <a:t>• Executes based on ha_meem_master_config.txt configuration</a:t>
-            </a:r>
-          </a:p>
-          <a:p>
-            <a:pPr>
-              <a:spcAft>
-                <a:spcPts val="800"/>
-              </a:spcAft>
-              <a:defRPr sz="1600">
-                <a:solidFill>
-                  <a:srgbClr val="F1F5F9"/>
-                </a:solidFill>
-              </a:defRPr>
-            </a:pPr>
-            <a:r>
-              <a:t>• Relies on compiled custom C++ parsers for output tensors</a:t>
-            </a:r>
-          </a:p>
-          <a:p>
-            <a:pPr>
-              <a:spcAft>
-                <a:spcPts val="800"/>
-              </a:spcAft>
-              <a:defRPr sz="1600">
-                <a:solidFill>
-                  <a:srgbClr val="F1F5F9"/>
-                </a:solidFill>
-              </a:defRPr>
-            </a:pPr>
-            <a:r>
-              <a:t>• Draws tracking boxes and displays performance scores</a:t>
-            </a:r>
-          </a:p>
-          <a:p>
-            <a:pPr>
-              <a:spcAft>
-                <a:spcPts val="800"/>
-              </a:spcAft>
-              <a:defRPr sz="1600">
-                <a:solidFill>
-                  <a:srgbClr val="F1F5F9"/>
-                </a:solidFill>
-              </a:defRPr>
-            </a:pPr>
-            <a:r>
-              <a:t>• Limitations: Cannot natively query Python database (FAISS) or run custom business logic</a:t>
+              <a:t>├── main.py                     &lt;-- GStreamer Orchestrator</a:t>
+            </a:r>
+            <a:br/>
+            <a:r>
+              <a:t>├── README.md                   &lt;-- Setup &amp; Run documentation</a:t>
+            </a:r>
+            <a:br/>
+            <a:r>
+              <a:t>├── configs/                    &lt;-- Local Config Copies</a:t>
+            </a:r>
+            <a:br/>
+            <a:r>
+              <a:t>│   ├── config_infer_primary.txt</a:t>
+            </a:r>
+            <a:br/>
+            <a:r>
+              <a:t>│   ├── config_infer_secondary.txt</a:t>
+            </a:r>
+            <a:br/>
+            <a:r>
+              <a:t>│   └── config_tracker_NvDCF_perf.yml</a:t>
+            </a:r>
+            <a:br/>
+            <a:r>
+              <a:t>└── custom_parser/              &lt;-- Local Parser Source</a:t>
+            </a:r>
+            <a:br/>
+            <a:r>
+              <a:t>    ├── nvdsinfer_custom_parser_scrfd.cpp</a:t>
+            </a:r>
+            <a:br/>
+            <a:r>
+              <a:t>    └── nvdsinfer_custom_parser_adaface.cpp</a:t>
             </a:r>
           </a:p>
         </p:txBody>
@@ -4573,90 +4679,59 @@
           <a:lstStyle/>
           <a:p>
             <a:pPr>
+              <a:spcAft>
+                <a:spcPts val="1000"/>
+              </a:spcAft>
               <a:defRPr sz="2200" b="1">
                 <a:solidFill>
-                  <a:srgbClr val="10B981"/>
+                  <a:srgbClr val="3B82F6"/>
                 </a:solidFill>
                 <a:latin typeface="Calibri"/>
               </a:defRPr>
             </a:pPr>
             <a:r>
-              <a:t>2. Python Custom Pipeline (Option B)</a:t>
+              <a:t>cpp_deepstream_pipeline/</a:t>
             </a:r>
           </a:p>
           <a:p>
             <a:pPr>
-              <a:spcAft>
-                <a:spcPts val="800"/>
-              </a:spcAft>
-              <a:defRPr sz="1600">
+              <a:defRPr sz="1300">
                 <a:solidFill>
                   <a:srgbClr val="F1F5F9"/>
                 </a:solidFill>
+                <a:latin typeface="Courier New"/>
               </a:defRPr>
             </a:pPr>
             <a:r>
-              <a:t>• GStreamer elements are created and run via Python GObject bindings</a:t>
-            </a:r>
-          </a:p>
-          <a:p>
-            <a:pPr>
-              <a:spcAft>
-                <a:spcPts val="800"/>
-              </a:spcAft>
-              <a:defRPr sz="1600">
-                <a:solidFill>
-                  <a:srgbClr val="F1F5F9"/>
-                </a:solidFill>
-              </a:defRPr>
-            </a:pPr>
-            <a:r>
-              <a:t>• Uses Python custom callbacks (Pad Probes) on inference outputs</a:t>
-            </a:r>
-          </a:p>
-          <a:p>
-            <a:pPr>
-              <a:spcAft>
-                <a:spcPts val="800"/>
-              </a:spcAft>
-              <a:defRPr sz="1600">
-                <a:solidFill>
-                  <a:srgbClr val="F1F5F9"/>
-                </a:solidFill>
-              </a:defRPr>
-            </a:pPr>
-            <a:r>
-              <a:t>• Extracts face embeddings on the fly &amp; queries FAISS face gallery</a:t>
-            </a:r>
-          </a:p>
-          <a:p>
-            <a:pPr>
-              <a:spcAft>
-                <a:spcPts val="800"/>
-              </a:spcAft>
-              <a:defRPr sz="1600">
-                <a:solidFill>
-                  <a:srgbClr val="F1F5F9"/>
-                </a:solidFill>
-              </a:defRPr>
-            </a:pPr>
-            <a:r>
-              <a:t>• Runs temporal consensus logic (EmbeddingAggregator)</a:t>
-            </a:r>
-          </a:p>
-          <a:p>
-            <a:pPr>
-              <a:spcAft>
-                <a:spcPts val="800"/>
-              </a:spcAft>
-              <a:defRPr sz="1600">
-                <a:solidFill>
-                  <a:srgbClr val="F1F5F9"/>
-                </a:solidFill>
-              </a:defRPr>
-            </a:pPr>
-            <a:r>
-              <a:t>• Logs events to JSONL and saves snapshot crops in background thread</a:t>
+              <a:t>├── README.md                   &lt;-- C++ Compile &amp; Setup guide</a:t>
+            </a:r>
+            <a:br/>
+            <a:r>
+              <a:t>├── configs/                    &lt;-- C++ native configuration files</a:t>
+            </a:r>
+            <a:br/>
+            <a:r>
+              <a:t>│   ├── ha_meem_master_config.txt</a:t>
+            </a:r>
+            <a:br/>
+            <a:r>
+              <a:t>│   ├── config_infer_primary.txt</a:t>
+            </a:r>
+            <a:br/>
+            <a:r>
+              <a:t>│   └── config_infer_secondary.txt</a:t>
+            </a:r>
+            <a:br/>
+            <a:r>
+              <a:t>└── custom_parser/              &lt;-- C++ custom parser files</a:t>
+            </a:r>
+            <a:br/>
+            <a:r>
+              <a:t>    ├── nvdsinfer_custom_parser_scrfd.cpp</a:t>
+            </a:r>
+            <a:br/>
+            <a:r>
+              <a:t>    └── nvdsinfer_custom_parser_adaface.cpp</a:t>
             </a:r>
           </a:p>
         </p:txBody>
@@ -4710,7 +4785,7 @@
           <a:lstStyle/>
           <a:p>
             <a:pPr>
-              <a:defRPr sz="3800" b="1">
+              <a:defRPr sz="3600" b="1">
                 <a:solidFill>
                   <a:srgbClr val="F1F5F9"/>
                 </a:solidFill>
@@ -4718,7 +4793,7 @@
               </a:defRPr>
             </a:pPr>
             <a:r>
-              <a:t>Why the Python Pipeline is Our Production Standard</a:t>
+              <a:t>C++ Native Pipeline: Configuration and Operation</a:t>
             </a:r>
           </a:p>
         </p:txBody>
@@ -4744,21 +4819,7 @@
             <a:spAutoFit/>
           </a:bodyPr>
           <a:lstStyle/>
-          <a:p>
-            <a:pPr>
-              <a:spcAft>
-                <a:spcPts val="1400"/>
-              </a:spcAft>
-              <a:defRPr sz="1800" b="1">
-                <a:solidFill>
-                  <a:srgbClr val="10B981"/>
-                </a:solidFill>
-              </a:defRPr>
-            </a:pPr>
-            <a:r>
-              <a:t>Option B (Python Pipeline) is recommended for production deployment because:</a:t>
-            </a:r>
-          </a:p>
+          <a:p/>
           <a:p>
             <a:pPr>
               <a:spcAft>
@@ -4766,20 +4827,20 @@
               </a:spcAft>
               <a:defRPr sz="1600" b="1">
                 <a:solidFill>
+                  <a:srgbClr val="3B82F6"/>
+                </a:solidFill>
+              </a:defRPr>
+            </a:pPr>
+            <a:r>
+              <a:t>✔ Binary-Driven Execution: </a:t>
+            </a:r>
+            <a:r>
+              <a:rPr sz="1400">
+                <a:solidFill>
                   <a:srgbClr val="F1F5F9"/>
                 </a:solidFill>
-              </a:defRPr>
-            </a:pPr>
-            <a:r>
-              <a:t>✔ Full Identity Matching: </a:t>
-            </a:r>
-            <a:r>
-              <a:rPr sz="1400">
-                <a:solidFill>
-                  <a:srgbClr val="94A3B8"/>
-                </a:solidFill>
               </a:rPr>
-              <a:t>Unlike C++, Python accesses the FAISS database (FaceDatabase) and maps the 512-dimension face vectors to actual employee IDs and names in real-time.</a:t>
+              <a:t>The C++ pipeline is executed by feeding the config files directly into the compiled native deepstream-app binary. No Python interpreter is used.</a:t>
             </a:r>
           </a:p>
           <a:p>
@@ -4789,20 +4850,20 @@
               </a:spcAft>
               <a:defRPr sz="1600" b="1">
                 <a:solidFill>
+                  <a:srgbClr val="3B82F6"/>
+                </a:solidFill>
+              </a:defRPr>
+            </a:pPr>
+            <a:r>
+              <a:t>✔ Config Parsing (`ha_meem_master_config.txt`): </a:t>
+            </a:r>
+            <a:r>
+              <a:rPr sz="1400">
+                <a:solidFill>
                   <a:srgbClr val="F1F5F9"/>
                 </a:solidFill>
-              </a:defRPr>
-            </a:pPr>
-            <a:r>
-              <a:t>✔ Temporal Consensus Aggregator: </a:t>
-            </a:r>
-            <a:r>
-              <a:rPr sz="1400">
-                <a:solidFill>
-                  <a:srgbClr val="94A3B8"/>
-                </a:solidFill>
               </a:rPr>
-              <a:t>Averaging face crops over a sliding window (using EmbeddingAggregator) drastically reduces facial matching noise. A visitor passing through doesn't trigger false alerts on a single bad frame.</a:t>
+              <a:t>Serves as the main blueprint, declaring sources, tiled display sizes, tracker files, and sub-infer properties.</a:t>
             </a:r>
           </a:p>
           <a:p>
@@ -4812,20 +4873,20 @@
               </a:spcAft>
               <a:defRPr sz="1600" b="1">
                 <a:solidFill>
+                  <a:srgbClr val="3B82F6"/>
+                </a:solidFill>
+              </a:defRPr>
+            </a:pPr>
+            <a:r>
+              <a:t>✔ C++ Custom Bounding Box Parser: </a:t>
+            </a:r>
+            <a:r>
+              <a:rPr sz="1400">
+                <a:solidFill>
                   <a:srgbClr val="F1F5F9"/>
                 </a:solidFill>
-              </a:defRPr>
-            </a:pPr>
-            <a:r>
-              <a:t>✔ Non-blocking Background I/O: </a:t>
-            </a:r>
-            <a:r>
-              <a:rPr sz="1400">
-                <a:solidFill>
-                  <a:srgbClr val="94A3B8"/>
-                </a:solidFill>
               </a:rPr>
-              <a:t>When an alert triggers, the frame is copied lazily from GPU memory to CPU memory and written as a JPEG. The database write is offloaded to a background thread worker (AsyncIOWorker). This keeps the main GPU streaming loop running at full speed without dropping frames.</a:t>
+              <a:t>SCRFD outputs anchors across three strides. We compile nvdsinfer_custom_parser_scrfd.cpp into libnvdsinfer_custom_impl_scrfd.so to decode the spatial bounding boxes on-the-fly.</a:t>
             </a:r>
           </a:p>
           <a:p>
@@ -4835,20 +4896,20 @@
               </a:spcAft>
               <a:defRPr sz="1600" b="1">
                 <a:solidFill>
+                  <a:srgbClr val="3B82F6"/>
+                </a:solidFill>
+              </a:defRPr>
+            </a:pPr>
+            <a:r>
+              <a:t>✔ Compiled Embeddings Recognition: </a:t>
+            </a:r>
+            <a:r>
+              <a:rPr sz="1400">
+                <a:solidFill>
                   <a:srgbClr val="F1F5F9"/>
                 </a:solidFill>
-              </a:defRPr>
-            </a:pPr>
-            <a:r>
-              <a:t>✔ Dynamic Camera Support: </a:t>
-            </a:r>
-            <a:r>
-              <a:rPr sz="1400">
-                <a:solidFill>
-                  <a:srgbClr val="94A3B8"/>
-                </a:solidFill>
               </a:rPr>
-              <a:t>Reads the root YAML files (default.yaml, thresholds.yaml, and cameras.yaml) dynamically to set up camera feeds, unlike C++ which requires manual text file updates.</a:t>
+              <a:t>The custom C++ parser (nvdsinfer_custom_parser_adaface.cpp) reads gallery_embeddings.txt into memory at runtime and maps vectors to identities natively inside C++.</a:t>
             </a:r>
           </a:p>
         </p:txBody>
@@ -4902,7 +4963,7 @@
           <a:lstStyle/>
           <a:p>
             <a:pPr>
-              <a:defRPr sz="3800" b="1">
+              <a:defRPr sz="3600" b="1">
                 <a:solidFill>
                   <a:srgbClr val="F1F5F9"/>
                 </a:solidFill>
@@ -4910,7 +4971,7 @@
               </a:defRPr>
             </a:pPr>
             <a:r>
-              <a:t>Directory Segregation and Legacy Cleanup</a:t>
+              <a:t>Python Pipeline: Custom Control &amp; FAISS Integration</a:t>
             </a:r>
           </a:p>
         </p:txBody>
@@ -4924,7 +4985,7 @@
         <p:spPr>
           <a:xfrm>
             <a:off x="685800" y="1645920"/>
-            <a:ext cx="5120640" cy="4114800"/>
+            <a:ext cx="10817352" cy="4114800"/>
           </a:xfrm>
           <a:prstGeom prst="rect">
             <a:avLst/>
@@ -4936,191 +4997,97 @@
             <a:spAutoFit/>
           </a:bodyPr>
           <a:lstStyle/>
+          <a:p/>
           <a:p>
             <a:pPr>
               <a:spcAft>
                 <a:spcPts val="1000"/>
               </a:spcAft>
-              <a:defRPr sz="2200" b="1">
+              <a:defRPr sz="1600" b="1">
                 <a:solidFill>
                   <a:srgbClr val="10B981"/>
                 </a:solidFill>
-                <a:latin typeface="Calibri"/>
               </a:defRPr>
             </a:pPr>
             <a:r>
-              <a:t>New Clean Directory Layout</a:t>
-            </a:r>
-          </a:p>
-          <a:p>
-            <a:pPr>
-              <a:defRPr sz="1300">
+              <a:t>✔ Python GStreamer Bindings: </a:t>
+            </a:r>
+            <a:r>
+              <a:rPr sz="1400">
                 <a:solidFill>
                   <a:srgbClr val="F1F5F9"/>
                 </a:solidFill>
-                <a:latin typeface="Courier New"/>
-              </a:defRPr>
-            </a:pPr>
-            <a:r>
-              <a:t>ha_meem_ai_surveillance/</a:t>
-            </a:r>
-            <a:br/>
-            <a:r>
-              <a:t>├── python_deepstream_pipeline/  &lt;-- Python Bindings (main.py)</a:t>
-            </a:r>
-            <a:br/>
-            <a:r>
-              <a:t>├── cpp_deepstream_pipeline/     &lt;-- C++ deepstream-app Configs</a:t>
-            </a:r>
-            <a:br/>
-            <a:r>
-              <a:t>├── apps/</a:t>
-            </a:r>
-            <a:br/>
-            <a:r>
-              <a:t>│   ├── alert_bot/               &lt;-- WhatsApp Selenium Bot</a:t>
-            </a:r>
-            <a:br/>
-            <a:r>
-              <a:t>│   ├── api_server/              &lt;-- FastAPI Log Event Stream</a:t>
-            </a:r>
-            <a:br/>
-            <a:r>
-              <a:t>│   └── dataset_tools/           &lt;-- Database Embeddings Compiler</a:t>
-            </a:r>
-            <a:br/>
-            <a:r>
-              <a:t>├── core/                        &lt;-- Shared Core Modules</a:t>
-            </a:r>
-            <a:br/>
-            <a:r>
-              <a:t>└── configs/                     &lt;-- default, thresholds, cameras.yaml</a:t>
-            </a:r>
-          </a:p>
-        </p:txBody>
-      </p:sp>
-      <p:sp>
-        <p:nvSpPr>
-          <p:cNvPr id="4" name="TextBox 3"/>
-          <p:cNvSpPr txBox="1"/>
-          <p:nvPr/>
-        </p:nvSpPr>
-        <p:spPr>
-          <a:xfrm>
-            <a:off x="6217920" y="1645920"/>
-            <a:ext cx="5120640" cy="4114800"/>
-          </a:xfrm>
-          <a:prstGeom prst="rect">
-            <a:avLst/>
-          </a:prstGeom>
-          <a:noFill/>
-        </p:spPr>
-        <p:txBody>
-          <a:bodyPr wrap="square">
-            <a:spAutoFit/>
-          </a:bodyPr>
-          <a:lstStyle/>
+              </a:rPr>
+              <a:t>Elements are initialized programmatically in Python using GObject bindings (e.g. Gst.ElementFactory.make) and assembled into a pipeline.</a:t>
+            </a:r>
+          </a:p>
           <a:p>
             <a:pPr>
               <a:spcAft>
                 <a:spcPts val="1000"/>
               </a:spcAft>
-              <a:defRPr sz="2200" b="1">
-                <a:solidFill>
-                  <a:srgbClr val="EF4444"/>
-                </a:solidFill>
-                <a:latin typeface="Calibri"/>
+              <a:defRPr sz="1600" b="1">
+                <a:solidFill>
+                  <a:srgbClr val="10B981"/>
+                </a:solidFill>
               </a:defRPr>
             </a:pPr>
             <a:r>
-              <a:t>Legacy Modules Deleted</a:t>
+              <a:t>✔ Metadata Pad Probe Callbacks: </a:t>
+            </a:r>
+            <a:r>
+              <a:rPr sz="1400">
+                <a:solidFill>
+                  <a:srgbClr val="F1F5F9"/>
+                </a:solidFill>
+              </a:rPr>
+              <a:t>Attaches a Python callback probe (sgie_src_pad_probe) to the source pad of the secondary GIE to capture tensor data as it flows through.</a:t>
             </a:r>
           </a:p>
           <a:p>
             <a:pPr>
               <a:spcAft>
-                <a:spcPts val="800"/>
+                <a:spcPts val="1000"/>
               </a:spcAft>
-              <a:defRPr sz="1400">
-                <a:solidFill>
-                  <a:srgbClr val="94A3B8"/>
+              <a:defRPr sz="1600" b="1">
+                <a:solidFill>
+                  <a:srgbClr val="10B981"/>
                 </a:solidFill>
               </a:defRPr>
             </a:pPr>
             <a:r>
-              <a:t>✗ apps/entry_pipeline/ (Old CPU Multi-Camera runner)</a:t>
+              <a:t>✔ FAISS Database Integration: </a:t>
+            </a:r>
+            <a:r>
+              <a:rPr sz="1400">
+                <a:solidFill>
+                  <a:srgbClr val="F1F5F9"/>
+                </a:solidFill>
+              </a:rPr>
+              <a:t>Embeddings are extracted from the buffer metadata and matched against a binary FAISS database (gallery_embeddings_80px_faiss.npy) using cosine similarity.</a:t>
             </a:r>
           </a:p>
           <a:p>
             <a:pPr>
               <a:spcAft>
-                <a:spcPts val="800"/>
+                <a:spcPts val="1000"/>
               </a:spcAft>
-              <a:defRPr sz="1400">
-                <a:solidFill>
-                  <a:srgbClr val="94A3B8"/>
+              <a:defRPr sz="1600" b="1">
+                <a:solidFill>
+                  <a:srgbClr val="10B981"/>
                 </a:solidFill>
               </a:defRPr>
             </a:pPr>
             <a:r>
-              <a:t>✗ core/camera/ (Legacy CPU Thread camera worker)</a:t>
-            </a:r>
-          </a:p>
-          <a:p>
-            <a:pPr>
-              <a:spcAft>
-                <a:spcPts val="800"/>
-              </a:spcAft>
-              <a:defRPr sz="1400">
-                <a:solidFill>
-                  <a:srgbClr val="94A3B8"/>
-                </a:solidFill>
-              </a:defRPr>
-            </a:pPr>
-            <a:r>
-              <a:t>✗ core/tracking/ (Legacy Python ByteTracker)</a:t>
-            </a:r>
-          </a:p>
-          <a:p>
-            <a:pPr>
-              <a:spcAft>
-                <a:spcPts val="800"/>
-              </a:spcAft>
-              <a:defRPr sz="1400">
-                <a:solidFill>
-                  <a:srgbClr val="94A3B8"/>
-                </a:solidFill>
-              </a:defRPr>
-            </a:pPr>
-            <a:r>
-              <a:t>✗ core/quality/ (Legacy Laplacian CPU blur checks)</a:t>
-            </a:r>
-          </a:p>
-          <a:p>
-            <a:pPr>
-              <a:spcAft>
-                <a:spcPts val="800"/>
-              </a:spcAft>
-              <a:defRPr sz="1400">
-                <a:solidFill>
-                  <a:srgbClr val="94A3B8"/>
-                </a:solidFill>
-              </a:defRPr>
-            </a:pPr>
-            <a:r>
-              <a:t>✗ system_profiler_traditional.py &amp; performance_traditional.md</a:t>
-            </a:r>
-          </a:p>
-          <a:p>
-            <a:pPr>
-              <a:defRPr sz="1200" i="1">
-                <a:solidFill>
-                  <a:srgbClr val="3B82F6"/>
-                </a:solidFill>
-              </a:defRPr>
-            </a:pPr>
-            <a:r>
-              <a:t>Note: core/detection &amp; core/recognition are kept purely to support apps/dataset_tools so you can generate gallery embeddings when registering new employees.</a:t>
+              <a:t>✔ Temporal Consensus Filters: </a:t>
+            </a:r>
+            <a:r>
+              <a:rPr sz="1400">
+                <a:solidFill>
+                  <a:srgbClr val="F1F5F9"/>
+                </a:solidFill>
+              </a:rPr>
+              <a:t>Maintains an embedding history window for each tracked face. This ensures that transient noise or lighting shifts do not trigger incorrect matching decisions.</a:t>
             </a:r>
           </a:p>
         </p:txBody>
@@ -5174,7 +5141,7 @@
           <a:lstStyle/>
           <a:p>
             <a:pPr>
-              <a:defRPr sz="3800" b="1">
+              <a:defRPr sz="3600" b="1">
                 <a:solidFill>
                   <a:srgbClr val="F1F5F9"/>
                 </a:solidFill>
@@ -5182,7 +5149,7 @@
               </a:defRPr>
             </a:pPr>
             <a:r>
-              <a:t>Decoupled Event-Driven Alerting Flow</a:t>
+              <a:t>Pipeline Optimization: GPU Zero-Copy Memory Flow</a:t>
             </a:r>
           </a:p>
         </p:txBody>
@@ -5221,7 +5188,7 @@
               </a:defRPr>
             </a:pPr>
             <a:r>
-              <a:t>➔ Step 1: Detection &amp; Matching (main.py): </a:t>
+              <a:t>✦ NVIDIA Video Memory Management (NVMM): </a:t>
             </a:r>
             <a:r>
               <a:rPr sz="1400">
@@ -5229,7 +5196,7 @@
                   <a:srgbClr val="F1F5F9"/>
                 </a:solidFill>
               </a:rPr>
-              <a:t>GPU detects, tracks, and extracts embeddings. If a status change occurs, the data is pushed to a background thread.</a:t>
+              <a:t>The multiplexer and inference elements are configured to use cuda-device buffers (nvbuf-memory-type=0). The video frames stay on the GPU memory during all pipeline operations.</a:t>
             </a:r>
           </a:p>
           <a:p>
@@ -5244,7 +5211,7 @@
               </a:defRPr>
             </a:pPr>
             <a:r>
-              <a:t>➔ Step 2: Log Writing (AsyncIOWorker): </a:t>
+              <a:t>✦ No Host CPU Memory Copies: </a:t>
             </a:r>
             <a:r>
               <a:rPr sz="1400">
@@ -5252,7 +5219,7 @@
                   <a:srgbClr val="F1F5F9"/>
                 </a:solidFill>
               </a:rPr>
-              <a:t>The background thread writes the JSON event to logs/events.jsonl and saves the crop in snapshots/ (completely non-blocking).</a:t>
+              <a:t>Frame matrices are never copied into the system's host RAM (CPU memory) during ingestion, decoding, face detection, tracking, or OSD overlay rendering.</a:t>
             </a:r>
           </a:p>
           <a:p>
@@ -5267,7 +5234,7 @@
               </a:defRPr>
             </a:pPr>
             <a:r>
-              <a:t>➔ Step 3: FastAPI Event Stream (api_server): </a:t>
+              <a:t>✦ Metadata-Only Tensor Parsing: </a:t>
             </a:r>
             <a:r>
               <a:rPr sz="1400">
@@ -5275,7 +5242,7 @@
                   <a:srgbClr val="F1F5F9"/>
                 </a:solidFill>
               </a:rPr>
-              <a:t>FastAPI tails logs/events.jsonl. It buffers events and exposes them via REST APIs and real-time Server-Sent Events (SSE).</a:t>
+              <a:t>The custom parsers only copy lightweight tensor data (like bounding boxes and 512-dimension float arrays) to system memory, avoiding large memory copies.</a:t>
             </a:r>
           </a:p>
           <a:p>
@@ -5290,7 +5257,7 @@
               </a:defRPr>
             </a:pPr>
             <a:r>
-              <a:t>➔ Step 4: Automated Alerts (whatsapp_bot): </a:t>
+              <a:t>✦ Lazy Frame Extraction: </a:t>
             </a:r>
             <a:r>
               <a:rPr sz="1400">
@@ -5298,7 +5265,7 @@
                   <a:srgbClr val="F1F5F9"/>
                 </a:solidFill>
               </a:rPr>
-              <a:t>A Selenium-driven bot polls the FastAPI server and pushes text alerts and face crop snapshots directly to WhatsApp Web in a separate, isolated process.</a:t>
+              <a:t>If a recognized status changes or an alert is triggered, GStreamer performs a lazy-copy of that specific frame buffer to the CPU for saving snapshots, keeping the rest of the stream on the GPU.</a:t>
             </a:r>
           </a:p>
         </p:txBody>
@@ -5352,7 +5319,7 @@
           <a:lstStyle/>
           <a:p>
             <a:pPr>
-              <a:defRPr sz="3800" b="1">
+              <a:defRPr sz="3600" b="1">
                 <a:solidFill>
                   <a:srgbClr val="F1F5F9"/>
                 </a:solidFill>
@@ -5360,7 +5327,7 @@
               </a:defRPr>
             </a:pPr>
             <a:r>
-              <a:t>Summary &amp; Next Steps</a:t>
+              <a:t>Summary of Engine Configurations</a:t>
             </a:r>
           </a:p>
         </p:txBody>
@@ -5386,34 +5353,28 @@
             <a:spAutoFit/>
           </a:bodyPr>
           <a:lstStyle/>
-          <a:p>
-            <a:pPr>
-              <a:spcAft>
-                <a:spcPts val="1400"/>
-              </a:spcAft>
-              <a:defRPr sz="1800" b="1">
-                <a:solidFill>
-                  <a:srgbClr val="10B981"/>
-                </a:solidFill>
-              </a:defRPr>
-            </a:pPr>
-            <a:r>
-              <a:t>Key Takeaways for Management:</a:t>
-            </a:r>
-          </a:p>
+          <a:p/>
           <a:p>
             <a:pPr>
               <a:spcAft>
                 <a:spcPts val="1000"/>
               </a:spcAft>
-              <a:defRPr sz="1600">
+              <a:defRPr sz="1600" b="1">
+                <a:solidFill>
+                  <a:srgbClr val="10B981"/>
+                </a:solidFill>
+              </a:defRPr>
+            </a:pPr>
+            <a:r>
+              <a:t>✔ Multi-Stream Multiplexing: </a:t>
+            </a:r>
+            <a:r>
+              <a:rPr sz="1400">
                 <a:solidFill>
                   <a:srgbClr val="F1F5F9"/>
                 </a:solidFill>
-              </a:defRPr>
-            </a:pPr>
-            <a:r>
-              <a:t>✔ 100% GPU Acceleration: By switching to DeepStream, CPU bottlenecks are resolved, allowing efficient multi-camera scaling.</a:t>
+              </a:rPr>
+              <a:t>Configured to multiplex three cameras in sync with a live-source push timeout of 40ms, preventing lag.</a:t>
             </a:r>
           </a:p>
           <a:p>
@@ -5421,14 +5382,22 @@
               <a:spcAft>
                 <a:spcPts val="1000"/>
               </a:spcAft>
-              <a:defRPr sz="1600">
+              <a:defRPr sz="1600" b="1">
+                <a:solidFill>
+                  <a:srgbClr val="10B981"/>
+                </a:solidFill>
+              </a:defRPr>
+            </a:pPr>
+            <a:r>
+              <a:t>✔ Primary Detector Batch Size: </a:t>
+            </a:r>
+            <a:r>
+              <a:rPr sz="1400">
                 <a:solidFill>
                   <a:srgbClr val="F1F5F9"/>
                 </a:solidFill>
-              </a:defRPr>
-            </a:pPr>
-            <a:r>
-              <a:t>✔ Production Ready: Option B (Python GStreamer bindings) integrates all FAISS gallery checks, consensus filtering, and logging.</a:t>
+              </a:rPr>
+              <a:t>Face detector (SCRFD) is configured with batch-size=3. TensorRT processes three frames (one from each camera) concurrently in a single GPU inference pass.</a:t>
             </a:r>
           </a:p>
           <a:p>
@@ -5436,14 +5405,22 @@
               <a:spcAft>
                 <a:spcPts val="1000"/>
               </a:spcAft>
-              <a:defRPr sz="1600">
+              <a:defRPr sz="1600" b="1">
+                <a:solidFill>
+                  <a:srgbClr val="10B981"/>
+                </a:solidFill>
+              </a:defRPr>
+            </a:pPr>
+            <a:r>
+              <a:t>✔ Secondary Classifier Batch Size: </a:t>
+            </a:r>
+            <a:r>
+              <a:rPr sz="1400">
                 <a:solidFill>
                   <a:srgbClr val="F1F5F9"/>
                 </a:solidFill>
-              </a:defRPr>
-            </a:pPr>
-            <a:r>
-              <a:t>✔ Decoupled &amp; Robust: If external notification services fail or lag, core surveillance is unaffected.</a:t>
+              </a:rPr>
+              <a:t>The AdaFace embedding model is configured with batch-size=16. This allows it to process up to 16 face chips from the three streams simultaneously in one step.</a:t>
             </a:r>
           </a:p>
           <a:p>
@@ -5451,14 +5428,412 @@
               <a:spcAft>
                 <a:spcPts val="1000"/>
               </a:spcAft>
-              <a:defRPr sz="1600">
+              <a:defRPr sz="1600" b="1">
+                <a:solidFill>
+                  <a:srgbClr val="10B981"/>
+                </a:solidFill>
+              </a:defRPr>
+            </a:pPr>
+            <a:r>
+              <a:t>✔ Static Model Input Profiles: </a:t>
+            </a:r>
+            <a:r>
+              <a:rPr sz="1400">
                 <a:solidFill>
                   <a:srgbClr val="F1F5F9"/>
                 </a:solidFill>
+              </a:rPr>
+              <a:t>The SCRFD ONNX input was compiled to static 640x640 dimensions. This fixes the dynamic TensorRT engine building failures and ensures stable GPU compilation.</a:t>
+            </a:r>
+          </a:p>
+        </p:txBody>
+      </p:sp>
+    </p:spTree>
+  </p:cSld>
+  <p:clrMapOvr>
+    <a:masterClrMapping/>
+  </p:clrMapOvr>
+</p:sld>
+</file>
+
+<file path=ppt/slides/slide8.xml><?xml version="1.0" encoding="utf-8"?>
+<p:sld xmlns:a="http://schemas.openxmlformats.org/drawingml/2006/main" xmlns:p="http://schemas.openxmlformats.org/presentationml/2006/main" xmlns:r="http://schemas.openxmlformats.org/officeDocument/2006/relationships">
+  <p:cSld>
+    <p:bg>
+      <p:bgPr>
+        <a:solidFill>
+          <a:srgbClr val="0F172A"/>
+        </a:solidFill>
+        <a:effectLst/>
+      </p:bgPr>
+    </p:bg>
+    <p:spTree>
+      <p:nvGrpSpPr>
+        <p:cNvPr id="1" name=""/>
+        <p:cNvGrpSpPr/>
+        <p:nvPr/>
+      </p:nvGrpSpPr>
+      <p:grpSpPr/>
+      <p:sp>
+        <p:nvSpPr>
+          <p:cNvPr id="2" name="TextBox 1"/>
+          <p:cNvSpPr txBox="1"/>
+          <p:nvPr/>
+        </p:nvSpPr>
+        <p:spPr>
+          <a:xfrm>
+            <a:off x="685800" y="457200"/>
+            <a:ext cx="10817352" cy="731520"/>
+          </a:xfrm>
+          <a:prstGeom prst="rect">
+            <a:avLst/>
+          </a:prstGeom>
+          <a:noFill/>
+        </p:spPr>
+        <p:txBody>
+          <a:bodyPr wrap="square" lIns="0" tIns="0" rIns="0" bIns="0">
+            <a:spAutoFit/>
+          </a:bodyPr>
+          <a:lstStyle/>
+          <a:p>
+            <a:pPr>
+              <a:defRPr sz="3600" b="1">
+                <a:solidFill>
+                  <a:srgbClr val="F1F5F9"/>
+                </a:solidFill>
+                <a:latin typeface="Calibri"/>
               </a:defRPr>
             </a:pPr>
             <a:r>
-              <a:t>✔ Next Steps: We are ready to run testing directly inside the Docker container on our target GPU hardware.</a:t>
+              <a:t>Independent Pipeline Compile &amp; Run Commands</a:t>
+            </a:r>
+          </a:p>
+        </p:txBody>
+      </p:sp>
+      <p:sp>
+        <p:nvSpPr>
+          <p:cNvPr id="3" name="TextBox 2"/>
+          <p:cNvSpPr txBox="1"/>
+          <p:nvPr/>
+        </p:nvSpPr>
+        <p:spPr>
+          <a:xfrm>
+            <a:off x="685800" y="1645920"/>
+            <a:ext cx="5120640" cy="4114800"/>
+          </a:xfrm>
+          <a:prstGeom prst="rect">
+            <a:avLst/>
+          </a:prstGeom>
+          <a:noFill/>
+        </p:spPr>
+        <p:txBody>
+          <a:bodyPr wrap="square">
+            <a:spAutoFit/>
+          </a:bodyPr>
+          <a:lstStyle/>
+          <a:p>
+            <a:pPr>
+              <a:spcAft>
+                <a:spcPts val="800"/>
+              </a:spcAft>
+              <a:defRPr sz="2000" b="1">
+                <a:solidFill>
+                  <a:srgbClr val="10B981"/>
+                </a:solidFill>
+                <a:latin typeface="Calibri"/>
+              </a:defRPr>
+            </a:pPr>
+            <a:r>
+              <a:t>Python DeepStream Execution</a:t>
+            </a:r>
+          </a:p>
+          <a:p>
+            <a:pPr>
+              <a:defRPr sz="1000">
+                <a:solidFill>
+                  <a:srgbClr val="F1F5F9"/>
+                </a:solidFill>
+                <a:latin typeface="Courier New"/>
+              </a:defRPr>
+            </a:pPr>
+            <a:r>
+              <a:t># 1. Compile Parsers in Python dir</a:t>
+            </a:r>
+            <a:br/>
+            <a:r>
+              <a:t>cd /app/python_deepstream_pipeline/custom_parser</a:t>
+            </a:r>
+            <a:br/>
+            <a:r>
+              <a:t>g++ -shared -fPIC -o libnvdsinfer_custom_impl_scrfd.so nvdsinfer_custom_parser_scrfd.cpp -Iinclude -I/opt/nvidia/deepstream/deepstream/sources/includes -I/usr/local/cuda/include -O3 -std=c++17</a:t>
+            </a:r>
+            <a:br/>
+            <a:r>
+              <a:t>g++ -shared -fPIC -o libnvdsinfer_custom_impl_adaface.so nvdsinfer_custom_parser_adaface.cpp -Iinclude -I/opt/nvidia/deepstream/deepstream/sources/includes -I/usr/local/cuda/include -O3 -std=c++17</a:t>
+            </a:r>
+            <a:br/>
+            <a:br/>
+            <a:r>
+              <a:t># 2. Start the Pipeline</a:t>
+            </a:r>
+            <a:br/>
+            <a:r>
+              <a:t>python3 /app/python_deepstream_pipeline/main.py</a:t>
+            </a:r>
+          </a:p>
+        </p:txBody>
+      </p:sp>
+      <p:sp>
+        <p:nvSpPr>
+          <p:cNvPr id="4" name="TextBox 3"/>
+          <p:cNvSpPr txBox="1"/>
+          <p:nvPr/>
+        </p:nvSpPr>
+        <p:spPr>
+          <a:xfrm>
+            <a:off x="6217920" y="1645920"/>
+            <a:ext cx="5120640" cy="4114800"/>
+          </a:xfrm>
+          <a:prstGeom prst="rect">
+            <a:avLst/>
+          </a:prstGeom>
+          <a:noFill/>
+        </p:spPr>
+        <p:txBody>
+          <a:bodyPr wrap="square">
+            <a:spAutoFit/>
+          </a:bodyPr>
+          <a:lstStyle/>
+          <a:p>
+            <a:pPr>
+              <a:spcAft>
+                <a:spcPts val="800"/>
+              </a:spcAft>
+              <a:defRPr sz="2000" b="1">
+                <a:solidFill>
+                  <a:srgbClr val="3B82F6"/>
+                </a:solidFill>
+                <a:latin typeface="Calibri"/>
+              </a:defRPr>
+            </a:pPr>
+            <a:r>
+              <a:t>C++ Native Execution</a:t>
+            </a:r>
+          </a:p>
+          <a:p>
+            <a:pPr>
+              <a:defRPr sz="1000">
+                <a:solidFill>
+                  <a:srgbClr val="F1F5F9"/>
+                </a:solidFill>
+                <a:latin typeface="Courier New"/>
+              </a:defRPr>
+            </a:pPr>
+            <a:r>
+              <a:t># 1. Compile Parsers in C++ dir</a:t>
+            </a:r>
+            <a:br/>
+            <a:r>
+              <a:t>cd /app/cpp_deepstream_pipeline/custom_parser</a:t>
+            </a:r>
+            <a:br/>
+            <a:r>
+              <a:t>g++ -shared -fPIC -o libnvdsinfer_custom_impl_scrfd.so nvdsinfer_custom_parser_scrfd.cpp -Iinclude -I/opt/nvidia/deepstream/deepstream/sources/includes -I/usr/local/cuda/include -O3 -std=c++17</a:t>
+            </a:r>
+            <a:br/>
+            <a:r>
+              <a:t>g++ -shared -fPIC -o libnvdsinfer_custom_impl_adaface.so nvdsinfer_custom_parser_adaface.cpp -Iinclude -I/opt/nvidia/deepstream/deepstream/sources/includes -I/usr/local/cuda/include -O3 -std=c++17</a:t>
+            </a:r>
+            <a:br/>
+            <a:br/>
+            <a:r>
+              <a:t># 2. Start deepstream-app</a:t>
+            </a:r>
+            <a:br/>
+            <a:r>
+              <a:t>cd /app/cpp_deepstream_pipeline/configs</a:t>
+            </a:r>
+            <a:br/>
+            <a:r>
+              <a:t>deepstream-app -c ha_meem_master_config.txt</a:t>
+            </a:r>
+          </a:p>
+        </p:txBody>
+      </p:sp>
+    </p:spTree>
+  </p:cSld>
+  <p:clrMapOvr>
+    <a:masterClrMapping/>
+  </p:clrMapOvr>
+</p:sld>
+</file>
+
+<file path=ppt/slides/slide9.xml><?xml version="1.0" encoding="utf-8"?>
+<p:sld xmlns:a="http://schemas.openxmlformats.org/drawingml/2006/main" xmlns:p="http://schemas.openxmlformats.org/presentationml/2006/main" xmlns:r="http://schemas.openxmlformats.org/officeDocument/2006/relationships">
+  <p:cSld>
+    <p:bg>
+      <p:bgPr>
+        <a:solidFill>
+          <a:srgbClr val="0F172A"/>
+        </a:solidFill>
+        <a:effectLst/>
+      </p:bgPr>
+    </p:bg>
+    <p:spTree>
+      <p:nvGrpSpPr>
+        <p:cNvPr id="1" name=""/>
+        <p:cNvGrpSpPr/>
+        <p:nvPr/>
+      </p:nvGrpSpPr>
+      <p:grpSpPr/>
+      <p:sp>
+        <p:nvSpPr>
+          <p:cNvPr id="2" name="TextBox 1"/>
+          <p:cNvSpPr txBox="1"/>
+          <p:nvPr/>
+        </p:nvSpPr>
+        <p:spPr>
+          <a:xfrm>
+            <a:off x="685800" y="457200"/>
+            <a:ext cx="10817352" cy="731520"/>
+          </a:xfrm>
+          <a:prstGeom prst="rect">
+            <a:avLst/>
+          </a:prstGeom>
+          <a:noFill/>
+        </p:spPr>
+        <p:txBody>
+          <a:bodyPr wrap="square" lIns="0" tIns="0" rIns="0" bIns="0">
+            <a:spAutoFit/>
+          </a:bodyPr>
+          <a:lstStyle/>
+          <a:p>
+            <a:pPr>
+              <a:defRPr sz="3600" b="1">
+                <a:solidFill>
+                  <a:srgbClr val="F1F5F9"/>
+                </a:solidFill>
+                <a:latin typeface="Calibri"/>
+              </a:defRPr>
+            </a:pPr>
+            <a:r>
+              <a:t>Post-Pipeline: Downstream Event Flow &amp; WhatsApp Alerts</a:t>
+            </a:r>
+          </a:p>
+        </p:txBody>
+      </p:sp>
+      <p:sp>
+        <p:nvSpPr>
+          <p:cNvPr id="3" name="TextBox 2"/>
+          <p:cNvSpPr txBox="1"/>
+          <p:nvPr/>
+        </p:nvSpPr>
+        <p:spPr>
+          <a:xfrm>
+            <a:off x="685800" y="1645920"/>
+            <a:ext cx="10817352" cy="4114800"/>
+          </a:xfrm>
+          <a:prstGeom prst="rect">
+            <a:avLst/>
+          </a:prstGeom>
+          <a:noFill/>
+        </p:spPr>
+        <p:txBody>
+          <a:bodyPr wrap="square">
+            <a:spAutoFit/>
+          </a:bodyPr>
+          <a:lstStyle/>
+          <a:p/>
+          <a:p>
+            <a:pPr>
+              <a:spcAft>
+                <a:spcPts val="1000"/>
+              </a:spcAft>
+              <a:defRPr sz="1600" b="1">
+                <a:solidFill>
+                  <a:srgbClr val="10B981"/>
+                </a:solidFill>
+              </a:defRPr>
+            </a:pPr>
+            <a:r>
+              <a:t>✦ Structured Local Outputs: </a:t>
+            </a:r>
+            <a:r>
+              <a:rPr sz="1400">
+                <a:solidFill>
+                  <a:srgbClr val="F1F5F9"/>
+                </a:solidFill>
+              </a:rPr>
+              <a:t>The active GStreamer pipeline records events to 'logs/events.jsonl' and crops face snapshots to the 'snapshots/' directory in real-time.</a:t>
+            </a:r>
+          </a:p>
+          <a:p>
+            <a:pPr>
+              <a:spcAft>
+                <a:spcPts val="1000"/>
+              </a:spcAft>
+              <a:defRPr sz="1600" b="1">
+                <a:solidFill>
+                  <a:srgbClr val="10B981"/>
+                </a:solidFill>
+              </a:defRPr>
+            </a:pPr>
+            <a:r>
+              <a:t>✦ FastAPI Server (apps/api_server/main.py): </a:t>
+            </a:r>
+            <a:r>
+              <a:rPr sz="1400">
+                <a:solidFill>
+                  <a:srgbClr val="F1F5F9"/>
+                </a:solidFill>
+              </a:rPr>
+              <a:t>Exposes the local events log over HTTP, offering REST endpoints and a Server-Sent Events (SSE) stream for real-time dashboard updates.</a:t>
+            </a:r>
+          </a:p>
+          <a:p>
+            <a:pPr>
+              <a:spcAft>
+                <a:spcPts val="1000"/>
+              </a:spcAft>
+              <a:defRPr sz="1600" b="1">
+                <a:solidFill>
+                  <a:srgbClr val="10B981"/>
+                </a:solidFill>
+              </a:defRPr>
+            </a:pPr>
+            <a:r>
+              <a:t>✦ WhatsApp Bot (apps/alert_bot/whatsapp_bot.py): </a:t>
+            </a:r>
+            <a:r>
+              <a:rPr sz="1400">
+                <a:solidFill>
+                  <a:srgbClr val="F1F5F9"/>
+                </a:solidFill>
+              </a:rPr>
+              <a:t>A background worker that polls the API server, compresses snapshot crops, and drives WhatsApp Web using Selenium to send instant alerts.</a:t>
+            </a:r>
+          </a:p>
+          <a:p>
+            <a:pPr>
+              <a:spcAft>
+                <a:spcPts val="1000"/>
+              </a:spcAft>
+              <a:defRPr sz="1600" b="1">
+                <a:solidFill>
+                  <a:srgbClr val="10B981"/>
+                </a:solidFill>
+              </a:defRPr>
+            </a:pPr>
+            <a:r>
+              <a:t>✦ Asynchronous Post-Inference Lifecycle: </a:t>
+            </a:r>
+            <a:r>
+              <a:rPr sz="1400">
+                <a:solidFill>
+                  <a:srgbClr val="F1F5F9"/>
+                </a:solidFill>
+              </a:rPr>
+              <a:t>Decoupling the pipelines from the alert handler ensures that alerts are queued and dispatched safely without blocking or slowing down the primary video inference thread.</a:t>
             </a:r>
           </a:p>
         </p:txBody>

</xml_diff>